<commit_message>
new edit made to logic and MD
</commit_message>
<xml_diff>
--- a/docs/Project_Presentation.pptx
+++ b/docs/Project_Presentation.pptx
@@ -857,7 +857,7 @@
           <a:p>
             <a:r>
               <a:rPr lang="en-US" dirty="0"/>
-              <a:t>Problem statement: LLM agents controlling a smart home are bad at scheduling requests, and the main failure is that they do not notice when a request contradicts itself. SimuHome (ICLR 2026) reports this as 'contradiction blindness' (85% of GPT-4.1's errors on infeasible scheduling, their Figure 4d). Gap: the scheduling tool only returns 'registered', and the paper's own self-correction experiments recover at most 18.5% (QT4-2) and 0% (QT4-3). Their suggested remedy, simulation-based pre-validation, is future work and heavy. Our idea: a small trained parser plus a Z3 consistency check placed in front of the tool; the large agent is not retrained.</a:t>
+              <a:t>Problem statement: LLM agents controlling a smart home are bad at scheduling requests, and the main failure is that they do not notice when a request contradicts itself. SimuHome (ICLR 2026) reports this as 'contradiction blindness' (85% of GPT-4.1's errors on infeasible scheduling, their Figure 4d). Gap: the scheduling tool only returns 'registered', and SimuHome's default prompt already tells the agent to stop on contradictions, yet GPT-4.1 still misses most of them. Their suggested remedy, simulation-based pre-validation, is future work and heavy. Our idea: a small trained parser plus a Z3 consistency check placed in front of the tool; the large agent is not retrained.</a:t>
             </a:r>
             <a:endParaRPr lang="en-US" dirty="0"/>
           </a:p>
@@ -945,7 +945,7 @@
           <a:p>
             <a:r>
               <a:rPr lang="en-US" dirty="0"/>
-              <a:t>Left: what the SimuHome authors measured. They evaluated 18 agents on 600 episodes; scheduling (QT4) is the hardest. In infeasible QT4 the dominant error is contradiction blindness (Fig. 4d: 85% for GPT-4.1; Table 11: 40/44, 25/33 and 30/34 errors for QT4-1/2/3). In section 5.3 they note the tool only confirms registration. In section 5.4 and Appendix M, asking the agent to review its own schedule recovered at most 18.5% of QT4-2 failures and 0% of QT4-3. Appendix L proposes simulation-based pre-validation as future work. Right: what we reuse. We keep SimuHome's simulator, episodes, ReAct agent and scorers unchanged and add a gate in front of schedule_workflow. The labels for training the parser come from the benchmark's own eval.goals and temporal_conflict fields. The idea of putting an SMT solver in front of tool calls comes from Agent-C (per our project handoff notes; its logic covers call order, we extend it to real-valued time). Tools: Z3, Qwen3-1.7B with LoRA, and Gemma-31B as the agent via NVIDIA's hosted API.</a:t>
+              <a:t>Left: what the SimuHome authors measured. They evaluated 18 agents on 600 episodes; scheduling (QT4) is the hardest. In infeasible QT4 the dominant error is contradiction blindness (Fig. 4d: 85% for GPT-4.1; Table 11: 40/44, 25/33 and 30/34 errors for QT4-1/2/3). In section 5.3 they note the tool only confirms registration. The default agent prompt already says to stop and tell the user about contradictions between relative and absolute times, yet the failure persists. In section 5.4 and Appendix M, a self-review experiment (the agent inspects and cancels its scheduled workflow after the fact) recovered at most 18.5% of QT4-2 and 0% of QT4-3 feasible-task failures; that is a different problem from checking for contradictions before scheduling. Appendix L proposes simulation-based pre-validation as future work. Right: what we reuse. We keep SimuHome's simulator, episodes, ReAct agent and scorers unchanged and add a gate in front of schedule_workflow. The labels for training the parser come from the benchmark's own eval.goals and temporal_conflict fields. The idea of putting an SMT solver in front of tool calls comes from Agent-C (per our project handoff notes; its logic covers call order, we extend it to real-valued time). Tools: Z3, Qwen3-1.7B with LoRA, and Gemma-31B as the agent via NVIDIA's hosted API.</a:t>
             </a:r>
             <a:endParaRPr lang="en-US" dirty="0"/>
           </a:p>
@@ -2150,7 +2150,7 @@
                 <a:ea typeface="Calibri" pitchFamily="34" charset="-122"/>
                 <a:cs typeface="Calibri" pitchFamily="34" charset="-120"/>
               </a:rPr>
-              <a:t>The scheduling tool only confirms registration. Self-correction prompts recover at most 18.5%; the paper’s fix, a simulator pre-check, is heavy.</a:t>
+              <a:t>The tool only confirms registration, and even a prompt warning about contradictions is not enough for GPT-4.1. The paper’s fix idea is heavy.</a:t>
             </a:r>
             <a:endParaRPr lang="en-US" sz="1400" dirty="0"/>
           </a:p>
@@ -2543,7 +2543,7 @@
                 <a:ea typeface="Calibri" pitchFamily="34" charset="-122"/>
                 <a:cs typeface="Calibri" pitchFamily="34" charset="-120"/>
               </a:rPr>
-              <a:t>Self-correction prompts barely help: recovery at most 18.5%, 0% on QT4-3</a:t>
+              <a:t>Its prompt already warns about contradictions, yet GPT-4.1 misses most; post-hoc self-review recovers at most 18.5%</a:t>
             </a:r>
             <a:endParaRPr lang="en-US" sz="1400" dirty="0"/>
           </a:p>

</xml_diff>